<commit_message>
250421 add dialogmsg for uninstalled version and function for uncheck it
</commit_message>
<xml_diff>
--- a/setup installer.pptx
+++ b/setup installer.pptx
@@ -15,6 +15,10 @@
     <p:sldId id="261" r:id="rId9"/>
     <p:sldId id="264" r:id="rId10"/>
     <p:sldId id="265" r:id="rId11"/>
+    <p:sldId id="266" r:id="rId12"/>
+    <p:sldId id="267" r:id="rId13"/>
+    <p:sldId id="268" r:id="rId14"/>
+    <p:sldId id="269" r:id="rId15"/>
   </p:sldIdLst>
   <p:sldSz cx="12192000" cy="6858000"/>
   <p:notesSz cx="6858000" cy="9144000"/>
@@ -113,6 +117,11 @@
       </a:defRPr>
     </a:lvl9pPr>
   </p:defaultTextStyle>
+  <p:extLst>
+    <p:ext uri="{EFAFB233-063F-42B5-8137-9DF3F51BA10A}">
+      <p15:sldGuideLst xmlns:p15="http://schemas.microsoft.com/office/powerpoint/2012/main"/>
+    </p:ext>
+  </p:extLst>
 </p:presentation>
 </file>
 
@@ -263,7 +272,7 @@
           <a:p>
             <a:fld id="{3EF23FE2-B3B7-4CA7-AE93-FEDF77A1D3BC}" type="datetimeFigureOut">
               <a:rPr lang="ko-KR" altLang="en-US" smtClean="0"/>
-              <a:t>2025-04-18</a:t>
+              <a:t>2025-04-21</a:t>
             </a:fld>
             <a:endParaRPr lang="ko-KR" altLang="en-US"/>
           </a:p>
@@ -461,7 +470,7 @@
           <a:p>
             <a:fld id="{3EF23FE2-B3B7-4CA7-AE93-FEDF77A1D3BC}" type="datetimeFigureOut">
               <a:rPr lang="ko-KR" altLang="en-US" smtClean="0"/>
-              <a:t>2025-04-18</a:t>
+              <a:t>2025-04-21</a:t>
             </a:fld>
             <a:endParaRPr lang="ko-KR" altLang="en-US"/>
           </a:p>
@@ -669,7 +678,7 @@
           <a:p>
             <a:fld id="{3EF23FE2-B3B7-4CA7-AE93-FEDF77A1D3BC}" type="datetimeFigureOut">
               <a:rPr lang="ko-KR" altLang="en-US" smtClean="0"/>
-              <a:t>2025-04-18</a:t>
+              <a:t>2025-04-21</a:t>
             </a:fld>
             <a:endParaRPr lang="ko-KR" altLang="en-US"/>
           </a:p>
@@ -867,7 +876,7 @@
           <a:p>
             <a:fld id="{3EF23FE2-B3B7-4CA7-AE93-FEDF77A1D3BC}" type="datetimeFigureOut">
               <a:rPr lang="ko-KR" altLang="en-US" smtClean="0"/>
-              <a:t>2025-04-18</a:t>
+              <a:t>2025-04-21</a:t>
             </a:fld>
             <a:endParaRPr lang="ko-KR" altLang="en-US"/>
           </a:p>
@@ -1142,7 +1151,7 @@
           <a:p>
             <a:fld id="{3EF23FE2-B3B7-4CA7-AE93-FEDF77A1D3BC}" type="datetimeFigureOut">
               <a:rPr lang="ko-KR" altLang="en-US" smtClean="0"/>
-              <a:t>2025-04-18</a:t>
+              <a:t>2025-04-21</a:t>
             </a:fld>
             <a:endParaRPr lang="ko-KR" altLang="en-US"/>
           </a:p>
@@ -1407,7 +1416,7 @@
           <a:p>
             <a:fld id="{3EF23FE2-B3B7-4CA7-AE93-FEDF77A1D3BC}" type="datetimeFigureOut">
               <a:rPr lang="ko-KR" altLang="en-US" smtClean="0"/>
-              <a:t>2025-04-18</a:t>
+              <a:t>2025-04-21</a:t>
             </a:fld>
             <a:endParaRPr lang="ko-KR" altLang="en-US"/>
           </a:p>
@@ -1819,7 +1828,7 @@
           <a:p>
             <a:fld id="{3EF23FE2-B3B7-4CA7-AE93-FEDF77A1D3BC}" type="datetimeFigureOut">
               <a:rPr lang="ko-KR" altLang="en-US" smtClean="0"/>
-              <a:t>2025-04-18</a:t>
+              <a:t>2025-04-21</a:t>
             </a:fld>
             <a:endParaRPr lang="ko-KR" altLang="en-US"/>
           </a:p>
@@ -1960,7 +1969,7 @@
           <a:p>
             <a:fld id="{3EF23FE2-B3B7-4CA7-AE93-FEDF77A1D3BC}" type="datetimeFigureOut">
               <a:rPr lang="ko-KR" altLang="en-US" smtClean="0"/>
-              <a:t>2025-04-18</a:t>
+              <a:t>2025-04-21</a:t>
             </a:fld>
             <a:endParaRPr lang="ko-KR" altLang="en-US"/>
           </a:p>
@@ -2073,7 +2082,7 @@
           <a:p>
             <a:fld id="{3EF23FE2-B3B7-4CA7-AE93-FEDF77A1D3BC}" type="datetimeFigureOut">
               <a:rPr lang="ko-KR" altLang="en-US" smtClean="0"/>
-              <a:t>2025-04-18</a:t>
+              <a:t>2025-04-21</a:t>
             </a:fld>
             <a:endParaRPr lang="ko-KR" altLang="en-US"/>
           </a:p>
@@ -2384,7 +2393,7 @@
           <a:p>
             <a:fld id="{3EF23FE2-B3B7-4CA7-AE93-FEDF77A1D3BC}" type="datetimeFigureOut">
               <a:rPr lang="ko-KR" altLang="en-US" smtClean="0"/>
-              <a:t>2025-04-18</a:t>
+              <a:t>2025-04-21</a:t>
             </a:fld>
             <a:endParaRPr lang="ko-KR" altLang="en-US"/>
           </a:p>
@@ -2672,7 +2681,7 @@
           <a:p>
             <a:fld id="{3EF23FE2-B3B7-4CA7-AE93-FEDF77A1D3BC}" type="datetimeFigureOut">
               <a:rPr lang="ko-KR" altLang="en-US" smtClean="0"/>
-              <a:t>2025-04-18</a:t>
+              <a:t>2025-04-21</a:t>
             </a:fld>
             <a:endParaRPr lang="ko-KR" altLang="en-US"/>
           </a:p>
@@ -2913,7 +2922,7 @@
           <a:p>
             <a:fld id="{3EF23FE2-B3B7-4CA7-AE93-FEDF77A1D3BC}" type="datetimeFigureOut">
               <a:rPr lang="ko-KR" altLang="en-US" smtClean="0"/>
-              <a:t>2025-04-18</a:t>
+              <a:t>2025-04-21</a:t>
             </a:fld>
             <a:endParaRPr lang="ko-KR" altLang="en-US"/>
           </a:p>
@@ -3766,6 +3775,216 @@
 </p:sld>
 </file>
 
+<file path=ppt/slides/slide11.xml><?xml version="1.0" encoding="utf-8"?>
+<p:sld xmlns:a="http://schemas.openxmlformats.org/drawingml/2006/main" xmlns:r="http://schemas.openxmlformats.org/officeDocument/2006/relationships" xmlns:p="http://schemas.openxmlformats.org/presentationml/2006/main">
+  <p:cSld>
+    <p:spTree>
+      <p:nvGrpSpPr>
+        <p:cNvPr id="1" name=""/>
+        <p:cNvGrpSpPr/>
+        <p:nvPr/>
+      </p:nvGrpSpPr>
+      <p:grpSpPr>
+        <a:xfrm>
+          <a:off x="0" y="0"/>
+          <a:ext cx="0" cy="0"/>
+          <a:chOff x="0" y="0"/>
+          <a:chExt cx="0" cy="0"/>
+        </a:xfrm>
+      </p:grpSpPr>
+    </p:spTree>
+    <p:extLst>
+      <p:ext uri="{BB962C8B-B14F-4D97-AF65-F5344CB8AC3E}">
+        <p14:creationId xmlns:p14="http://schemas.microsoft.com/office/powerpoint/2010/main" val="2979980939"/>
+      </p:ext>
+    </p:extLst>
+  </p:cSld>
+  <p:clrMapOvr>
+    <a:masterClrMapping/>
+  </p:clrMapOvr>
+</p:sld>
+</file>
+
+<file path=ppt/slides/slide12.xml><?xml version="1.0" encoding="utf-8"?>
+<p:sld xmlns:a="http://schemas.openxmlformats.org/drawingml/2006/main" xmlns:r="http://schemas.openxmlformats.org/officeDocument/2006/relationships" xmlns:p="http://schemas.openxmlformats.org/presentationml/2006/main">
+  <p:cSld>
+    <p:spTree>
+      <p:nvGrpSpPr>
+        <p:cNvPr id="1" name=""/>
+        <p:cNvGrpSpPr/>
+        <p:nvPr/>
+      </p:nvGrpSpPr>
+      <p:grpSpPr>
+        <a:xfrm>
+          <a:off x="0" y="0"/>
+          <a:ext cx="0" cy="0"/>
+          <a:chOff x="0" y="0"/>
+          <a:chExt cx="0" cy="0"/>
+        </a:xfrm>
+      </p:grpSpPr>
+      <p:pic>
+        <p:nvPicPr>
+          <p:cNvPr id="3" name="그림 2">
+            <a:extLst>
+              <a:ext uri="{FF2B5EF4-FFF2-40B4-BE49-F238E27FC236}">
+                <a16:creationId xmlns:a16="http://schemas.microsoft.com/office/drawing/2014/main" id="{8933C8C5-8ACA-3008-57EF-A33646E6C3AC}"/>
+              </a:ext>
+            </a:extLst>
+          </p:cNvPr>
+          <p:cNvPicPr>
+            <a:picLocks noChangeAspect="1"/>
+          </p:cNvPicPr>
+          <p:nvPr/>
+        </p:nvPicPr>
+        <p:blipFill>
+          <a:blip r:embed="rId2"/>
+          <a:stretch>
+            <a:fillRect/>
+          </a:stretch>
+        </p:blipFill>
+        <p:spPr>
+          <a:xfrm>
+            <a:off x="3395" y="0"/>
+            <a:ext cx="4696480" cy="3686689"/>
+          </a:xfrm>
+          <a:prstGeom prst="rect">
+            <a:avLst/>
+          </a:prstGeom>
+        </p:spPr>
+      </p:pic>
+      <p:pic>
+        <p:nvPicPr>
+          <p:cNvPr id="5" name="그림 4">
+            <a:extLst>
+              <a:ext uri="{FF2B5EF4-FFF2-40B4-BE49-F238E27FC236}">
+                <a16:creationId xmlns:a16="http://schemas.microsoft.com/office/drawing/2014/main" id="{7C28F068-B6A6-5E8B-40F1-7986F2436322}"/>
+              </a:ext>
+            </a:extLst>
+          </p:cNvPr>
+          <p:cNvPicPr>
+            <a:picLocks noChangeAspect="1"/>
+          </p:cNvPicPr>
+          <p:nvPr/>
+        </p:nvPicPr>
+        <p:blipFill>
+          <a:blip r:embed="rId3"/>
+          <a:stretch>
+            <a:fillRect/>
+          </a:stretch>
+        </p:blipFill>
+        <p:spPr>
+          <a:xfrm>
+            <a:off x="4699875" y="0"/>
+            <a:ext cx="4772691" cy="3648584"/>
+          </a:xfrm>
+          <a:prstGeom prst="rect">
+            <a:avLst/>
+          </a:prstGeom>
+        </p:spPr>
+      </p:pic>
+      <p:pic>
+        <p:nvPicPr>
+          <p:cNvPr id="7" name="그림 6">
+            <a:extLst>
+              <a:ext uri="{FF2B5EF4-FFF2-40B4-BE49-F238E27FC236}">
+                <a16:creationId xmlns:a16="http://schemas.microsoft.com/office/drawing/2014/main" id="{65BDD3CE-1A04-94A5-4DDF-262F6B302AC6}"/>
+              </a:ext>
+            </a:extLst>
+          </p:cNvPr>
+          <p:cNvPicPr>
+            <a:picLocks noChangeAspect="1"/>
+          </p:cNvPicPr>
+          <p:nvPr/>
+        </p:nvPicPr>
+        <p:blipFill>
+          <a:blip r:embed="rId4"/>
+          <a:stretch>
+            <a:fillRect/>
+          </a:stretch>
+        </p:blipFill>
+        <p:spPr>
+          <a:xfrm>
+            <a:off x="7492125" y="3190363"/>
+            <a:ext cx="4696480" cy="3667637"/>
+          </a:xfrm>
+          <a:prstGeom prst="rect">
+            <a:avLst/>
+          </a:prstGeom>
+        </p:spPr>
+      </p:pic>
+    </p:spTree>
+    <p:extLst>
+      <p:ext uri="{BB962C8B-B14F-4D97-AF65-F5344CB8AC3E}">
+        <p14:creationId xmlns:p14="http://schemas.microsoft.com/office/powerpoint/2010/main" val="1172840570"/>
+      </p:ext>
+    </p:extLst>
+  </p:cSld>
+  <p:clrMapOvr>
+    <a:masterClrMapping/>
+  </p:clrMapOvr>
+</p:sld>
+</file>
+
+<file path=ppt/slides/slide13.xml><?xml version="1.0" encoding="utf-8"?>
+<p:sld xmlns:a="http://schemas.openxmlformats.org/drawingml/2006/main" xmlns:r="http://schemas.openxmlformats.org/officeDocument/2006/relationships" xmlns:p="http://schemas.openxmlformats.org/presentationml/2006/main">
+  <p:cSld>
+    <p:spTree>
+      <p:nvGrpSpPr>
+        <p:cNvPr id="1" name=""/>
+        <p:cNvGrpSpPr/>
+        <p:nvPr/>
+      </p:nvGrpSpPr>
+      <p:grpSpPr>
+        <a:xfrm>
+          <a:off x="0" y="0"/>
+          <a:ext cx="0" cy="0"/>
+          <a:chOff x="0" y="0"/>
+          <a:chExt cx="0" cy="0"/>
+        </a:xfrm>
+      </p:grpSpPr>
+    </p:spTree>
+    <p:extLst>
+      <p:ext uri="{BB962C8B-B14F-4D97-AF65-F5344CB8AC3E}">
+        <p14:creationId xmlns:p14="http://schemas.microsoft.com/office/powerpoint/2010/main" val="1602022328"/>
+      </p:ext>
+    </p:extLst>
+  </p:cSld>
+  <p:clrMapOvr>
+    <a:masterClrMapping/>
+  </p:clrMapOvr>
+</p:sld>
+</file>
+
+<file path=ppt/slides/slide14.xml><?xml version="1.0" encoding="utf-8"?>
+<p:sld xmlns:a="http://schemas.openxmlformats.org/drawingml/2006/main" xmlns:r="http://schemas.openxmlformats.org/officeDocument/2006/relationships" xmlns:p="http://schemas.openxmlformats.org/presentationml/2006/main">
+  <p:cSld>
+    <p:spTree>
+      <p:nvGrpSpPr>
+        <p:cNvPr id="1" name=""/>
+        <p:cNvGrpSpPr/>
+        <p:nvPr/>
+      </p:nvGrpSpPr>
+      <p:grpSpPr>
+        <a:xfrm>
+          <a:off x="0" y="0"/>
+          <a:ext cx="0" cy="0"/>
+          <a:chOff x="0" y="0"/>
+          <a:chExt cx="0" cy="0"/>
+        </a:xfrm>
+      </p:grpSpPr>
+    </p:spTree>
+    <p:extLst>
+      <p:ext uri="{BB962C8B-B14F-4D97-AF65-F5344CB8AC3E}">
+        <p14:creationId xmlns:p14="http://schemas.microsoft.com/office/powerpoint/2010/main" val="4061745166"/>
+      </p:ext>
+    </p:extLst>
+  </p:cSld>
+  <p:clrMapOvr>
+    <a:masterClrMapping/>
+  </p:clrMapOvr>
+</p:sld>
+</file>
+
 <file path=ppt/slides/slide2.xml><?xml version="1.0" encoding="utf-8"?>
 <p:sld xmlns:a="http://schemas.openxmlformats.org/drawingml/2006/main" xmlns:r="http://schemas.openxmlformats.org/officeDocument/2006/relationships" xmlns:p="http://schemas.openxmlformats.org/presentationml/2006/main">
   <p:cSld>

</xml_diff>

<commit_message>
250421 Change Language Eng to Kor
</commit_message>
<xml_diff>
--- a/setup installer.pptx
+++ b/setup installer.pptx
@@ -3942,6 +3942,126 @@
           <a:chExt cx="0" cy="0"/>
         </a:xfrm>
       </p:grpSpPr>
+      <p:pic>
+        <p:nvPicPr>
+          <p:cNvPr id="3" name="그림 2">
+            <a:extLst>
+              <a:ext uri="{FF2B5EF4-FFF2-40B4-BE49-F238E27FC236}">
+                <a16:creationId xmlns:a16="http://schemas.microsoft.com/office/drawing/2014/main" id="{27A6FDFA-5DCF-8293-E432-3C58089024FA}"/>
+              </a:ext>
+            </a:extLst>
+          </p:cNvPr>
+          <p:cNvPicPr>
+            <a:picLocks noChangeAspect="1"/>
+          </p:cNvPicPr>
+          <p:nvPr/>
+        </p:nvPicPr>
+        <p:blipFill>
+          <a:blip r:embed="rId2"/>
+          <a:stretch>
+            <a:fillRect/>
+          </a:stretch>
+        </p:blipFill>
+        <p:spPr>
+          <a:xfrm>
+            <a:off x="4959978" y="0"/>
+            <a:ext cx="4734586" cy="3677163"/>
+          </a:xfrm>
+          <a:prstGeom prst="rect">
+            <a:avLst/>
+          </a:prstGeom>
+        </p:spPr>
+      </p:pic>
+      <p:pic>
+        <p:nvPicPr>
+          <p:cNvPr id="5" name="그림 4">
+            <a:extLst>
+              <a:ext uri="{FF2B5EF4-FFF2-40B4-BE49-F238E27FC236}">
+                <a16:creationId xmlns:a16="http://schemas.microsoft.com/office/drawing/2014/main" id="{E0D6BC73-B20C-13DB-A641-C91A7CEAA026}"/>
+              </a:ext>
+            </a:extLst>
+          </p:cNvPr>
+          <p:cNvPicPr>
+            <a:picLocks noChangeAspect="1"/>
+          </p:cNvPicPr>
+          <p:nvPr/>
+        </p:nvPicPr>
+        <p:blipFill>
+          <a:blip r:embed="rId3"/>
+          <a:stretch>
+            <a:fillRect/>
+          </a:stretch>
+        </p:blipFill>
+        <p:spPr>
+          <a:xfrm>
+            <a:off x="0" y="0"/>
+            <a:ext cx="4696480" cy="3667637"/>
+          </a:xfrm>
+          <a:prstGeom prst="rect">
+            <a:avLst/>
+          </a:prstGeom>
+        </p:spPr>
+      </p:pic>
+      <p:pic>
+        <p:nvPicPr>
+          <p:cNvPr id="7" name="그림 6">
+            <a:extLst>
+              <a:ext uri="{FF2B5EF4-FFF2-40B4-BE49-F238E27FC236}">
+                <a16:creationId xmlns:a16="http://schemas.microsoft.com/office/drawing/2014/main" id="{6F78DCCC-8A01-63CF-C708-2C5C4579476E}"/>
+              </a:ext>
+            </a:extLst>
+          </p:cNvPr>
+          <p:cNvPicPr>
+            <a:picLocks noChangeAspect="1"/>
+          </p:cNvPicPr>
+          <p:nvPr/>
+        </p:nvPicPr>
+        <p:blipFill>
+          <a:blip r:embed="rId4"/>
+          <a:stretch>
+            <a:fillRect/>
+          </a:stretch>
+        </p:blipFill>
+        <p:spPr>
+          <a:xfrm>
+            <a:off x="19052" y="3180837"/>
+            <a:ext cx="4677428" cy="3677163"/>
+          </a:xfrm>
+          <a:prstGeom prst="rect">
+            <a:avLst/>
+          </a:prstGeom>
+        </p:spPr>
+      </p:pic>
+      <p:pic>
+        <p:nvPicPr>
+          <p:cNvPr id="9" name="그림 8">
+            <a:extLst>
+              <a:ext uri="{FF2B5EF4-FFF2-40B4-BE49-F238E27FC236}">
+                <a16:creationId xmlns:a16="http://schemas.microsoft.com/office/drawing/2014/main" id="{1CB9EB2F-0379-0E12-BCB6-38D027101749}"/>
+              </a:ext>
+            </a:extLst>
+          </p:cNvPr>
+          <p:cNvPicPr>
+            <a:picLocks noChangeAspect="1"/>
+          </p:cNvPicPr>
+          <p:nvPr/>
+        </p:nvPicPr>
+        <p:blipFill>
+          <a:blip r:embed="rId5"/>
+          <a:stretch>
+            <a:fillRect/>
+          </a:stretch>
+        </p:blipFill>
+        <p:spPr>
+          <a:xfrm>
+            <a:off x="4959978" y="3142732"/>
+            <a:ext cx="4734586" cy="3715268"/>
+          </a:xfrm>
+          <a:prstGeom prst="rect">
+            <a:avLst/>
+          </a:prstGeom>
+        </p:spPr>
+      </p:pic>
     </p:spTree>
     <p:extLst>
       <p:ext uri="{BB962C8B-B14F-4D97-AF65-F5344CB8AC3E}">

</xml_diff>